<commit_message>
Add shared hosted buyer and merchant sessions
</commit_message>
<xml_diff>
--- a/outputs/errand-build-on-arc-pitch.pptx
+++ b/outputs/errand-build-on-arc-pitch.pptx
@@ -2,20 +2,20 @@
 <file path=ppt/presentation.xml><?xml version="1.0" encoding="utf-8"?>
 <p:presentation xmlns:p="http://schemas.openxmlformats.org/presentationml/2006/main">
   <p:sldMasterIdLst>
-    <p:sldMasterId xmlns:r="http://schemas.openxmlformats.org/officeDocument/2006/relationships" id="2147483648" r:id="R8885cb5e12a14aa4"/>
+    <p:sldMasterId xmlns:r="http://schemas.openxmlformats.org/officeDocument/2006/relationships" id="2147483648" r:id="R14bf73005b5e4721"/>
   </p:sldMasterIdLst>
   <p:notesMasterIdLst>
-    <p:notesMasterId xmlns:r="http://schemas.openxmlformats.org/officeDocument/2006/relationships" r:id="R30c00d00f6224925"/>
+    <p:notesMasterId xmlns:r="http://schemas.openxmlformats.org/officeDocument/2006/relationships" r:id="R311a93dbfaee4fd9"/>
   </p:notesMasterIdLst>
   <p:sldIdLst>
-    <p:sldId xmlns:r="http://schemas.openxmlformats.org/officeDocument/2006/relationships" id="256" r:id="Rd97ffead50574f71"/>
-    <p:sldId xmlns:r="http://schemas.openxmlformats.org/officeDocument/2006/relationships" id="257" r:id="R52f2d9870ed54bca"/>
-    <p:sldId xmlns:r="http://schemas.openxmlformats.org/officeDocument/2006/relationships" id="258" r:id="R4eacc8b37fcb4121"/>
-    <p:sldId xmlns:r="http://schemas.openxmlformats.org/officeDocument/2006/relationships" id="259" r:id="R854837db56974e7c"/>
-    <p:sldId xmlns:r="http://schemas.openxmlformats.org/officeDocument/2006/relationships" id="260" r:id="Re6f7faf3013341ef"/>
-    <p:sldId xmlns:r="http://schemas.openxmlformats.org/officeDocument/2006/relationships" id="261" r:id="R07bd4ffe98154763"/>
-    <p:sldId xmlns:r="http://schemas.openxmlformats.org/officeDocument/2006/relationships" id="262" r:id="R02d26b9b31734f98"/>
-    <p:sldId xmlns:r="http://schemas.openxmlformats.org/officeDocument/2006/relationships" id="263" r:id="R7ddb9b1b6192465d"/>
+    <p:sldId xmlns:r="http://schemas.openxmlformats.org/officeDocument/2006/relationships" id="256" r:id="Ra6bf15ef0af14f4a"/>
+    <p:sldId xmlns:r="http://schemas.openxmlformats.org/officeDocument/2006/relationships" id="257" r:id="R2aa5cc3e7dc8429f"/>
+    <p:sldId xmlns:r="http://schemas.openxmlformats.org/officeDocument/2006/relationships" id="258" r:id="Rbd090ff8826b4f2c"/>
+    <p:sldId xmlns:r="http://schemas.openxmlformats.org/officeDocument/2006/relationships" id="259" r:id="R7d13f15d27a14378"/>
+    <p:sldId xmlns:r="http://schemas.openxmlformats.org/officeDocument/2006/relationships" id="260" r:id="Rd90db24a6bf74f0b"/>
+    <p:sldId xmlns:r="http://schemas.openxmlformats.org/officeDocument/2006/relationships" id="261" r:id="R245f34f7f0d84c11"/>
+    <p:sldId xmlns:r="http://schemas.openxmlformats.org/officeDocument/2006/relationships" id="262" r:id="Rcf6481da81db40a3"/>
+    <p:sldId xmlns:r="http://schemas.openxmlformats.org/officeDocument/2006/relationships" id="263" r:id="R3eed8b3dfa5440b6"/>
   </p:sldIdLst>
   <p:sldSz cx="12192000" cy="6858000"/>
   <p:notesSz cx="6858000" cy="9144000"/>
@@ -1070,7 +1070,7 @@
   </p:cSld>
   <p:clrMap bg1="lt1" tx1="dk1" bg2="lt2" tx2="dk2" accent1="accent1" accent2="accent2" accent3="accent3" accent4="accent4" accent5="accent5" accent6="accent6" hlink="hlink" folHlink="folHlink"/>
   <p:sldLayoutIdLst>
-    <p:sldLayoutId xmlns:r="http://schemas.openxmlformats.org/officeDocument/2006/relationships" id="2147483649" r:id="R91eab2505cb74050"/>
+    <p:sldLayoutId xmlns:r="http://schemas.openxmlformats.org/officeDocument/2006/relationships" id="2147483649" r:id="R9096adceb9ba46c7"/>
   </p:sldLayoutIdLst>
   <p:txStyles>
     <p:titleStyle>
@@ -1639,6 +1639,7 @@
           <a:lstStyle xmlns:a="http://schemas.openxmlformats.org/drawingml/2006/main"/>
           <a:p xmlns:a="http://schemas.openxmlformats.org/drawingml/2006/main">
             <a:pPr algn="l">
+              <a:buNone/>
               <a:defRPr sz="6000">
                 <a:solidFill>
                   <a:srgbClr val="000000"/>
@@ -1685,6 +1686,7 @@
           <a:lstStyle xmlns:a="http://schemas.openxmlformats.org/drawingml/2006/main"/>
           <a:p xmlns:a="http://schemas.openxmlformats.org/drawingml/2006/main">
             <a:pPr algn="l">
+              <a:buNone/>
               <a:defRPr sz="2400">
                 <a:solidFill>
                   <a:srgbClr val="000000"/>
@@ -1730,6 +1732,7 @@
           <a:lstStyle xmlns:a="http://schemas.openxmlformats.org/drawingml/2006/main"/>
           <a:p xmlns:a="http://schemas.openxmlformats.org/drawingml/2006/main">
             <a:pPr algn="l">
+              <a:buNone/>
               <a:defRPr sz="2400">
                 <a:solidFill>
                   <a:srgbClr val="000000"/>
@@ -1797,6 +1800,7 @@
           <a:lstStyle xmlns:a="http://schemas.openxmlformats.org/drawingml/2006/main"/>
           <a:p xmlns:a="http://schemas.openxmlformats.org/drawingml/2006/main">
             <a:pPr algn="r">
+              <a:buNone/>
               <a:defRPr sz="1000">
                 <a:solidFill>
                   <a:srgbClr val="000000"/>
@@ -1842,6 +1846,7 @@
           <a:lstStyle xmlns:a="http://schemas.openxmlformats.org/drawingml/2006/main"/>
           <a:p xmlns:a="http://schemas.openxmlformats.org/drawingml/2006/main">
             <a:pPr algn="l">
+              <a:buNone/>
               <a:defRPr sz="2900">
                 <a:solidFill>
                   <a:srgbClr val="000000"/>
@@ -1916,6 +1921,7 @@
           <a:lstStyle xmlns:a="http://schemas.openxmlformats.org/drawingml/2006/main"/>
           <a:p xmlns:a="http://schemas.openxmlformats.org/drawingml/2006/main">
             <a:pPr algn="l">
+              <a:buNone/>
               <a:defRPr sz="2400">
                 <a:solidFill>
                   <a:srgbClr val="000000"/>
@@ -1962,6 +1968,7 @@
           <a:lstStyle xmlns:a="http://schemas.openxmlformats.org/drawingml/2006/main"/>
           <a:p xmlns:a="http://schemas.openxmlformats.org/drawingml/2006/main">
             <a:pPr algn="l">
+              <a:buNone/>
               <a:defRPr sz="1600">
                 <a:solidFill>
                   <a:srgbClr val="000000"/>
@@ -1978,6 +1985,7 @@
           </a:p>
           <a:p xmlns:a="http://schemas.openxmlformats.org/drawingml/2006/main">
             <a:pPr algn="l">
+              <a:buNone/>
               <a:defRPr sz="1600">
                 <a:solidFill>
                   <a:srgbClr val="000000"/>
@@ -1994,6 +2002,7 @@
           </a:p>
           <a:p xmlns:a="http://schemas.openxmlformats.org/drawingml/2006/main">
             <a:pPr algn="l">
+              <a:buNone/>
               <a:defRPr sz="1600">
                 <a:solidFill>
                   <a:srgbClr val="000000"/>
@@ -2068,6 +2077,7 @@
           <a:lstStyle xmlns:a="http://schemas.openxmlformats.org/drawingml/2006/main"/>
           <a:p xmlns:a="http://schemas.openxmlformats.org/drawingml/2006/main">
             <a:pPr algn="l">
+              <a:buNone/>
               <a:defRPr sz="2400">
                 <a:solidFill>
                   <a:srgbClr val="000000"/>
@@ -2114,6 +2124,7 @@
           <a:lstStyle xmlns:a="http://schemas.openxmlformats.org/drawingml/2006/main"/>
           <a:p xmlns:a="http://schemas.openxmlformats.org/drawingml/2006/main">
             <a:pPr algn="l">
+              <a:buNone/>
               <a:defRPr sz="1600">
                 <a:solidFill>
                   <a:srgbClr val="000000"/>
@@ -2130,6 +2141,7 @@
           </a:p>
           <a:p xmlns:a="http://schemas.openxmlformats.org/drawingml/2006/main">
             <a:pPr algn="l">
+              <a:buNone/>
               <a:defRPr sz="1600">
                 <a:solidFill>
                   <a:srgbClr val="000000"/>
@@ -2146,6 +2158,7 @@
           </a:p>
           <a:p xmlns:a="http://schemas.openxmlformats.org/drawingml/2006/main">
             <a:pPr algn="l">
+              <a:buNone/>
               <a:defRPr sz="1600">
                 <a:solidFill>
                   <a:srgbClr val="000000"/>
@@ -2191,6 +2204,7 @@
           <a:lstStyle xmlns:a="http://schemas.openxmlformats.org/drawingml/2006/main"/>
           <a:p xmlns:a="http://schemas.openxmlformats.org/drawingml/2006/main">
             <a:pPr algn="l">
+              <a:buNone/>
               <a:defRPr sz="1600">
                 <a:solidFill>
                   <a:srgbClr val="000000"/>
@@ -2207,6 +2221,7 @@
           </a:p>
           <a:p xmlns:a="http://schemas.openxmlformats.org/drawingml/2006/main">
             <a:pPr algn="l">
+              <a:buNone/>
               <a:defRPr sz="1600">
                 <a:solidFill>
                   <a:srgbClr val="000000"/>
@@ -2222,6 +2237,7 @@
           </a:p>
           <a:p xmlns:a="http://schemas.openxmlformats.org/drawingml/2006/main">
             <a:pPr algn="l">
+              <a:buNone/>
               <a:defRPr sz="1600">
                 <a:solidFill>
                   <a:srgbClr val="000000"/>
@@ -2287,6 +2303,7 @@
           <a:lstStyle xmlns:a="http://schemas.openxmlformats.org/drawingml/2006/main"/>
           <a:p xmlns:a="http://schemas.openxmlformats.org/drawingml/2006/main">
             <a:pPr algn="r">
+              <a:buNone/>
               <a:defRPr sz="1000">
                 <a:solidFill>
                   <a:srgbClr val="000000"/>
@@ -2332,6 +2349,7 @@
           <a:lstStyle xmlns:a="http://schemas.openxmlformats.org/drawingml/2006/main"/>
           <a:p xmlns:a="http://schemas.openxmlformats.org/drawingml/2006/main">
             <a:pPr algn="l">
+              <a:buNone/>
               <a:defRPr sz="2900">
                 <a:solidFill>
                   <a:srgbClr val="000000"/>
@@ -2349,7 +2367,7 @@
       </p:sp>
       <p:cxnSp>
         <p:nvCxnSpPr>
-          <p:cNvPr id="15" name="Google-Shape-2259-p159-4"/>
+          <p:cNvPr id="21" name="Google-Shape-2259-p159-4"/>
           <p:cNvCxnSpPr/>
           <p:nvPr/>
         </p:nvCxnSpPr>
@@ -2480,6 +2498,7 @@
           <a:lstStyle xmlns:a="http://schemas.openxmlformats.org/drawingml/2006/main"/>
           <a:p xmlns:a="http://schemas.openxmlformats.org/drawingml/2006/main">
             <a:pPr algn="l">
+              <a:buNone/>
               <a:defRPr sz="1600">
                 <a:solidFill>
                   <a:srgbClr val="000000"/>
@@ -2525,6 +2544,7 @@
           <a:lstStyle xmlns:a="http://schemas.openxmlformats.org/drawingml/2006/main"/>
           <a:p xmlns:a="http://schemas.openxmlformats.org/drawingml/2006/main">
             <a:pPr algn="l">
+              <a:buNone/>
               <a:defRPr sz="1600">
                 <a:solidFill>
                   <a:srgbClr val="000000"/>
@@ -2570,6 +2590,7 @@
           <a:lstStyle xmlns:a="http://schemas.openxmlformats.org/drawingml/2006/main"/>
           <a:p xmlns:a="http://schemas.openxmlformats.org/drawingml/2006/main">
             <a:pPr algn="l">
+              <a:buNone/>
               <a:defRPr sz="1600">
                 <a:solidFill>
                   <a:srgbClr val="000000"/>
@@ -2615,6 +2636,7 @@
           <a:lstStyle xmlns:a="http://schemas.openxmlformats.org/drawingml/2006/main"/>
           <a:p xmlns:a="http://schemas.openxmlformats.org/drawingml/2006/main">
             <a:pPr algn="l">
+              <a:buNone/>
               <a:defRPr sz="2400">
                 <a:solidFill>
                   <a:srgbClr val="000000"/>
@@ -2631,6 +2653,7 @@
           </a:p>
           <a:p xmlns:a="http://schemas.openxmlformats.org/drawingml/2006/main">
             <a:pPr algn="l">
+              <a:buNone/>
               <a:defRPr sz="2400">
                 <a:solidFill>
                   <a:srgbClr val="000000"/>
@@ -2676,6 +2699,7 @@
           <a:lstStyle xmlns:a="http://schemas.openxmlformats.org/drawingml/2006/main"/>
           <a:p xmlns:a="http://schemas.openxmlformats.org/drawingml/2006/main">
             <a:pPr algn="l">
+              <a:buNone/>
               <a:defRPr sz="2400">
                 <a:solidFill>
                   <a:srgbClr val="000000"/>
@@ -2692,6 +2716,7 @@
           </a:p>
           <a:p xmlns:a="http://schemas.openxmlformats.org/drawingml/2006/main">
             <a:pPr algn="l">
+              <a:buNone/>
               <a:defRPr sz="2400">
                 <a:solidFill>
                   <a:srgbClr val="000000"/>
@@ -2737,6 +2762,7 @@
           <a:lstStyle xmlns:a="http://schemas.openxmlformats.org/drawingml/2006/main"/>
           <a:p xmlns:a="http://schemas.openxmlformats.org/drawingml/2006/main">
             <a:pPr algn="l">
+              <a:buNone/>
               <a:defRPr sz="2400">
                 <a:solidFill>
                   <a:srgbClr val="000000"/>
@@ -2753,6 +2779,7 @@
           </a:p>
           <a:p xmlns:a="http://schemas.openxmlformats.org/drawingml/2006/main">
             <a:pPr algn="l">
+              <a:buNone/>
               <a:defRPr sz="2400">
                 <a:solidFill>
                   <a:srgbClr val="000000"/>
@@ -2818,6 +2845,7 @@
           <a:lstStyle xmlns:a="http://schemas.openxmlformats.org/drawingml/2006/main"/>
           <a:p xmlns:a="http://schemas.openxmlformats.org/drawingml/2006/main">
             <a:pPr algn="r">
+              <a:buNone/>
               <a:defRPr sz="1000">
                 <a:solidFill>
                   <a:srgbClr val="000000"/>
@@ -2863,6 +2891,7 @@
           <a:lstStyle xmlns:a="http://schemas.openxmlformats.org/drawingml/2006/main"/>
           <a:p xmlns:a="http://schemas.openxmlformats.org/drawingml/2006/main">
             <a:pPr algn="l">
+              <a:buNone/>
               <a:defRPr sz="2900">
                 <a:solidFill>
                   <a:srgbClr val="000000"/>
@@ -2906,6 +2935,7 @@
           <a:lstStyle xmlns:a="http://schemas.openxmlformats.org/drawingml/2006/main"/>
           <a:p xmlns:a="http://schemas.openxmlformats.org/drawingml/2006/main">
             <a:pPr algn="l">
+              <a:buNone/>
               <a:defRPr sz="2400">
                 <a:solidFill>
                   <a:srgbClr val="000000"/>
@@ -2922,6 +2952,7 @@
           </a:p>
           <a:p xmlns:a="http://schemas.openxmlformats.org/drawingml/2006/main">
             <a:pPr algn="l">
+              <a:buNone/>
               <a:defRPr sz="2400">
                 <a:solidFill>
                   <a:srgbClr val="000000"/>
@@ -2965,6 +2996,7 @@
           <a:lstStyle xmlns:a="http://schemas.openxmlformats.org/drawingml/2006/main"/>
           <a:p xmlns:a="http://schemas.openxmlformats.org/drawingml/2006/main">
             <a:pPr algn="l">
+              <a:buNone/>
               <a:defRPr sz="2400">
                 <a:solidFill>
                   <a:srgbClr val="000000"/>
@@ -2981,6 +3013,7 @@
           </a:p>
           <a:p xmlns:a="http://schemas.openxmlformats.org/drawingml/2006/main">
             <a:pPr algn="l">
+              <a:buNone/>
               <a:defRPr sz="2400">
                 <a:solidFill>
                   <a:srgbClr val="000000"/>
@@ -3026,6 +3059,7 @@
           <a:lstStyle xmlns:a="http://schemas.openxmlformats.org/drawingml/2006/main"/>
           <a:p xmlns:a="http://schemas.openxmlformats.org/drawingml/2006/main">
             <a:pPr algn="l">
+              <a:buNone/>
               <a:defRPr sz="2400">
                 <a:solidFill>
                   <a:srgbClr val="000000"/>
@@ -3042,6 +3076,7 @@
           </a:p>
           <a:p xmlns:a="http://schemas.openxmlformats.org/drawingml/2006/main">
             <a:pPr algn="l">
+              <a:buNone/>
               <a:defRPr sz="2400">
                 <a:solidFill>
                   <a:srgbClr val="000000"/>
@@ -3087,6 +3122,7 @@
           <a:lstStyle xmlns:a="http://schemas.openxmlformats.org/drawingml/2006/main"/>
           <a:p xmlns:a="http://schemas.openxmlformats.org/drawingml/2006/main">
             <a:pPr algn="l">
+              <a:buNone/>
               <a:defRPr sz="2400">
                 <a:solidFill>
                   <a:srgbClr val="000000"/>
@@ -3103,6 +3139,7 @@
           </a:p>
           <a:p xmlns:a="http://schemas.openxmlformats.org/drawingml/2006/main">
             <a:pPr algn="l">
+              <a:buNone/>
               <a:defRPr sz="2400">
                 <a:solidFill>
                   <a:srgbClr val="000000"/>
@@ -3168,6 +3205,7 @@
           <a:lstStyle xmlns:a="http://schemas.openxmlformats.org/drawingml/2006/main"/>
           <a:p xmlns:a="http://schemas.openxmlformats.org/drawingml/2006/main">
             <a:pPr algn="r">
+              <a:buNone/>
               <a:defRPr sz="1000">
                 <a:solidFill>
                   <a:srgbClr val="000000"/>
@@ -3213,6 +3251,7 @@
           <a:lstStyle xmlns:a="http://schemas.openxmlformats.org/drawingml/2006/main"/>
           <a:p xmlns:a="http://schemas.openxmlformats.org/drawingml/2006/main">
             <a:pPr algn="l">
+              <a:buNone/>
               <a:defRPr sz="2900">
                 <a:solidFill>
                   <a:srgbClr val="000000"/>
@@ -3256,6 +3295,7 @@
           <a:lstStyle xmlns:a="http://schemas.openxmlformats.org/drawingml/2006/main"/>
           <a:p xmlns:a="http://schemas.openxmlformats.org/drawingml/2006/main">
             <a:pPr algn="l">
+              <a:buNone/>
               <a:defRPr sz="2400">
                 <a:solidFill>
                   <a:srgbClr val="000000"/>
@@ -3272,6 +3312,7 @@
           </a:p>
           <a:p xmlns:a="http://schemas.openxmlformats.org/drawingml/2006/main">
             <a:pPr algn="l">
+              <a:buNone/>
               <a:defRPr sz="2400">
                 <a:solidFill>
                   <a:srgbClr val="000000"/>
@@ -3315,6 +3356,7 @@
           <a:lstStyle xmlns:a="http://schemas.openxmlformats.org/drawingml/2006/main"/>
           <a:p xmlns:a="http://schemas.openxmlformats.org/drawingml/2006/main">
             <a:pPr algn="l">
+              <a:buNone/>
               <a:defRPr sz="2400">
                 <a:solidFill>
                   <a:srgbClr val="000000"/>
@@ -3331,6 +3373,7 @@
           </a:p>
           <a:p xmlns:a="http://schemas.openxmlformats.org/drawingml/2006/main">
             <a:pPr algn="l">
+              <a:buNone/>
               <a:defRPr sz="2400">
                 <a:solidFill>
                   <a:srgbClr val="000000"/>
@@ -3376,6 +3419,7 @@
           <a:lstStyle xmlns:a="http://schemas.openxmlformats.org/drawingml/2006/main"/>
           <a:p xmlns:a="http://schemas.openxmlformats.org/drawingml/2006/main">
             <a:pPr algn="l">
+              <a:buNone/>
               <a:defRPr sz="2400">
                 <a:solidFill>
                   <a:srgbClr val="000000"/>
@@ -3392,6 +3436,7 @@
           </a:p>
           <a:p xmlns:a="http://schemas.openxmlformats.org/drawingml/2006/main">
             <a:pPr algn="l">
+              <a:buNone/>
               <a:defRPr sz="2400">
                 <a:solidFill>
                   <a:srgbClr val="000000"/>
@@ -3437,6 +3482,7 @@
           <a:lstStyle xmlns:a="http://schemas.openxmlformats.org/drawingml/2006/main"/>
           <a:p xmlns:a="http://schemas.openxmlformats.org/drawingml/2006/main">
             <a:pPr algn="l">
+              <a:buNone/>
               <a:defRPr sz="2400">
                 <a:solidFill>
                   <a:srgbClr val="000000"/>
@@ -3453,6 +3499,7 @@
           </a:p>
           <a:p xmlns:a="http://schemas.openxmlformats.org/drawingml/2006/main">
             <a:pPr algn="l">
+              <a:buNone/>
               <a:defRPr sz="2400">
                 <a:solidFill>
                   <a:srgbClr val="000000"/>
@@ -3605,6 +3652,7 @@
           <a:lstStyle xmlns:a="http://schemas.openxmlformats.org/drawingml/2006/main"/>
           <a:p xmlns:a="http://schemas.openxmlformats.org/drawingml/2006/main">
             <a:pPr algn="r">
+              <a:buNone/>
               <a:defRPr sz="1000">
                 <a:solidFill>
                   <a:srgbClr val="000000"/>
@@ -3650,6 +3698,7 @@
           <a:lstStyle xmlns:a="http://schemas.openxmlformats.org/drawingml/2006/main"/>
           <a:p xmlns:a="http://schemas.openxmlformats.org/drawingml/2006/main">
             <a:pPr algn="l">
+              <a:buNone/>
               <a:defRPr sz="2900">
                 <a:solidFill>
                   <a:srgbClr val="000000"/>
@@ -3660,7 +3709,7 @@
               </a:defRPr>
             </a:pPr>
             <a:r>
-              <a:t>The MVP has working Arc Testnet evidence</a:t>
+              <a:t>The full loop is completed on Arc Testnet</a:t>
             </a:r>
           </a:p>
         </p:txBody>
@@ -3695,6 +3744,7 @@
           <a:lstStyle xmlns:a="http://schemas.openxmlformats.org/drawingml/2006/main"/>
           <a:p xmlns:a="http://schemas.openxmlformats.org/drawingml/2006/main">
             <a:pPr algn="l">
+              <a:buNone/>
               <a:defRPr sz="2400">
                 <a:solidFill>
                   <a:srgbClr val="000000"/>
@@ -3741,6 +3791,7 @@
           <a:lstStyle xmlns:a="http://schemas.openxmlformats.org/drawingml/2006/main"/>
           <a:p xmlns:a="http://schemas.openxmlformats.org/drawingml/2006/main">
             <a:pPr algn="l">
+              <a:buNone/>
               <a:defRPr sz="2400">
                 <a:solidFill>
                   <a:srgbClr val="000000"/>
@@ -3751,8 +3802,8 @@
               </a:defRPr>
             </a:pPr>
             <a:r>
-              <a:t>automated tests
-passing</a:t>
+              <a:t>released on pickup
+0.00756 USDC gas</a:t>
             </a:r>
           </a:p>
         </p:txBody>
@@ -3787,6 +3838,7 @@
           <a:lstStyle xmlns:a="http://schemas.openxmlformats.org/drawingml/2006/main"/>
           <a:p xmlns:a="http://schemas.openxmlformats.org/drawingml/2006/main">
             <a:pPr algn="l">
+              <a:buNone/>
               <a:defRPr sz="2400">
                 <a:solidFill>
                   <a:srgbClr val="000000"/>
@@ -3833,6 +3885,7 @@
           <a:lstStyle xmlns:a="http://schemas.openxmlformats.org/drawingml/2006/main"/>
           <a:p xmlns:a="http://schemas.openxmlformats.org/drawingml/2006/main">
             <a:pPr algn="l">
+              <a:buNone/>
               <a:defRPr sz="2400">
                 <a:solidFill>
                   <a:srgbClr val="000000"/>
@@ -3878,6 +3931,7 @@
           <a:lstStyle xmlns:a="http://schemas.openxmlformats.org/drawingml/2006/main"/>
           <a:p xmlns:a="http://schemas.openxmlformats.org/drawingml/2006/main">
             <a:pPr algn="l">
+              <a:buNone/>
               <a:defRPr sz="2400">
                 <a:solidFill>
                   <a:srgbClr val="000000"/>
@@ -3923,6 +3977,7 @@
           <a:lstStyle xmlns:a="http://schemas.openxmlformats.org/drawingml/2006/main"/>
           <a:p xmlns:a="http://schemas.openxmlformats.org/drawingml/2006/main">
             <a:pPr algn="l">
+              <a:buNone/>
               <a:defRPr sz="2400">
                 <a:solidFill>
                   <a:srgbClr val="000000"/>
@@ -3933,7 +3988,7 @@
               </a:defRPr>
             </a:pPr>
             <a:r>
-              <a:t>23 / 23</a:t>
+              <a:t>1.5 USDC</a:t>
             </a:r>
           </a:p>
         </p:txBody>
@@ -3968,6 +4023,7 @@
           <a:lstStyle xmlns:a="http://schemas.openxmlformats.org/drawingml/2006/main"/>
           <a:p xmlns:a="http://schemas.openxmlformats.org/drawingml/2006/main">
             <a:pPr algn="l">
+              <a:buNone/>
               <a:defRPr sz="1600">
                 <a:solidFill>
                   <a:srgbClr val="000000"/>
@@ -3984,6 +4040,7 @@
           </a:p>
           <a:p xmlns:a="http://schemas.openxmlformats.org/drawingml/2006/main">
             <a:pPr algn="l">
+              <a:buNone/>
               <a:defRPr sz="1600">
                 <a:solidFill>
                   <a:srgbClr val="000000"/>
@@ -3994,7 +4051,7 @@
               </a:defRPr>
             </a:pPr>
             <a:r>
-              <a:t>A funded agent wallet bought merchant data, the corrected paid path returned signed quotes, and OrderEscrow is deployed with a complete browser-wallet lifecycle ready for the final recorded release.</a:t>
+              <a:t>A funded agent bought signed merchant quotes through x402, selected Can Butcher under policy, funded OrderEscrow, and released 1.5 USDC only after verified pickup.</a:t>
             </a:r>
           </a:p>
         </p:txBody>
@@ -4051,6 +4108,7 @@
           <a:lstStyle xmlns:a="http://schemas.openxmlformats.org/drawingml/2006/main"/>
           <a:p xmlns:a="http://schemas.openxmlformats.org/drawingml/2006/main">
             <a:pPr algn="r">
+              <a:buNone/>
               <a:defRPr sz="1000">
                 <a:solidFill>
                   <a:srgbClr val="000000"/>
@@ -4096,6 +4154,7 @@
           <a:lstStyle xmlns:a="http://schemas.openxmlformats.org/drawingml/2006/main"/>
           <a:p xmlns:a="http://schemas.openxmlformats.org/drawingml/2006/main">
             <a:pPr algn="l">
+              <a:buNone/>
               <a:defRPr sz="2900">
                 <a:solidFill>
                   <a:srgbClr val="000000"/>
@@ -4170,6 +4229,7 @@
           <a:lstStyle xmlns:a="http://schemas.openxmlformats.org/drawingml/2006/main"/>
           <a:p xmlns:a="http://schemas.openxmlformats.org/drawingml/2006/main">
             <a:pPr algn="l">
+              <a:buNone/>
               <a:defRPr sz="2400">
                 <a:solidFill>
                   <a:srgbClr val="000000"/>
@@ -4216,6 +4276,7 @@
           <a:lstStyle xmlns:a="http://schemas.openxmlformats.org/drawingml/2006/main"/>
           <a:p xmlns:a="http://schemas.openxmlformats.org/drawingml/2006/main">
             <a:pPr algn="l">
+              <a:buNone/>
               <a:defRPr sz="1600">
                 <a:solidFill>
                   <a:srgbClr val="000000"/>
@@ -4232,6 +4293,7 @@
           </a:p>
           <a:p xmlns:a="http://schemas.openxmlformats.org/drawingml/2006/main">
             <a:pPr algn="l">
+              <a:buNone/>
               <a:defRPr sz="1600">
                 <a:solidFill>
                   <a:srgbClr val="000000"/>
@@ -4248,6 +4310,7 @@
           </a:p>
           <a:p xmlns:a="http://schemas.openxmlformats.org/drawingml/2006/main">
             <a:pPr algn="l">
+              <a:buNone/>
               <a:defRPr sz="1600">
                 <a:solidFill>
                   <a:srgbClr val="000000"/>
@@ -4322,6 +4385,7 @@
           <a:lstStyle xmlns:a="http://schemas.openxmlformats.org/drawingml/2006/main"/>
           <a:p xmlns:a="http://schemas.openxmlformats.org/drawingml/2006/main">
             <a:pPr algn="l">
+              <a:buNone/>
               <a:defRPr sz="2400">
                 <a:solidFill>
                   <a:srgbClr val="000000"/>
@@ -4368,6 +4432,7 @@
           <a:lstStyle xmlns:a="http://schemas.openxmlformats.org/drawingml/2006/main"/>
           <a:p xmlns:a="http://schemas.openxmlformats.org/drawingml/2006/main">
             <a:pPr algn="l">
+              <a:buNone/>
               <a:defRPr sz="1600">
                 <a:solidFill>
                   <a:srgbClr val="000000"/>
@@ -4384,6 +4449,7 @@
           </a:p>
           <a:p xmlns:a="http://schemas.openxmlformats.org/drawingml/2006/main">
             <a:pPr algn="l">
+              <a:buNone/>
               <a:defRPr sz="1600">
                 <a:solidFill>
                   <a:srgbClr val="000000"/>
@@ -4400,6 +4466,7 @@
           </a:p>
           <a:p xmlns:a="http://schemas.openxmlformats.org/drawingml/2006/main">
             <a:pPr algn="l">
+              <a:buNone/>
               <a:defRPr sz="1600">
                 <a:solidFill>
                   <a:srgbClr val="000000"/>
@@ -4445,6 +4512,7 @@
           <a:lstStyle xmlns:a="http://schemas.openxmlformats.org/drawingml/2006/main"/>
           <a:p xmlns:a="http://schemas.openxmlformats.org/drawingml/2006/main">
             <a:pPr algn="l">
+              <a:buNone/>
               <a:defRPr sz="1600">
                 <a:solidFill>
                   <a:srgbClr val="000000"/>
@@ -4461,6 +4529,7 @@
           </a:p>
           <a:p xmlns:a="http://schemas.openxmlformats.org/drawingml/2006/main">
             <a:pPr algn="l">
+              <a:buNone/>
               <a:defRPr sz="1600">
                 <a:solidFill>
                   <a:srgbClr val="000000"/>
@@ -4476,6 +4545,7 @@
           </a:p>
           <a:p xmlns:a="http://schemas.openxmlformats.org/drawingml/2006/main">
             <a:pPr algn="l">
+              <a:buNone/>
               <a:defRPr sz="1600">
                 <a:solidFill>
                   <a:srgbClr val="000000"/>
@@ -4543,6 +4613,7 @@
           <a:lstStyle xmlns:a="http://schemas.openxmlformats.org/drawingml/2006/main"/>
           <a:p xmlns:a="http://schemas.openxmlformats.org/drawingml/2006/main">
             <a:pPr algn="l">
+              <a:buNone/>
               <a:defRPr sz="6000">
                 <a:solidFill>
                   <a:srgbClr val="000000"/>
@@ -4589,6 +4660,7 @@
           <a:lstStyle xmlns:a="http://schemas.openxmlformats.org/drawingml/2006/main"/>
           <a:p xmlns:a="http://schemas.openxmlformats.org/drawingml/2006/main">
             <a:pPr algn="l">
+              <a:buNone/>
               <a:defRPr sz="2400">
                 <a:solidFill>
                   <a:srgbClr val="000000"/>
@@ -4604,6 +4676,7 @@
           </a:p>
           <a:p xmlns:a="http://schemas.openxmlformats.org/drawingml/2006/main">
             <a:pPr algn="l">
+              <a:buNone/>
               <a:defRPr sz="2400">
                 <a:solidFill>
                   <a:srgbClr val="000000"/>
@@ -4619,6 +4692,7 @@
           </a:p>
           <a:p xmlns:a="http://schemas.openxmlformats.org/drawingml/2006/main">
             <a:pPr algn="l">
+              <a:buNone/>
               <a:defRPr sz="2400">
                 <a:solidFill>
                   <a:srgbClr val="000000"/>
@@ -4664,6 +4738,7 @@
           <a:lstStyle xmlns:a="http://schemas.openxmlformats.org/drawingml/2006/main"/>
           <a:p xmlns:a="http://schemas.openxmlformats.org/drawingml/2006/main">
             <a:pPr algn="l">
+              <a:buNone/>
               <a:defRPr sz="2400">
                 <a:solidFill>
                   <a:srgbClr val="000000"/>

</xml_diff>